<commit_message>
docs: sync updated PowerPoint with ScamBait AI Honeypot pillar
</commit_message>
<xml_diff>
--- a/AegisPay_Pitch_Deck.pptx
+++ b/AegisPay_Pitch_Deck.pptx
@@ -3431,12 +3431,12 @@
             <a:pPr algn="ctr">
               <a:defRPr sz="2200" b="1">
                 <a:solidFill>
-                  <a:srgbClr val="F59E0B"/>
-                </a:solidFill>
-              </a:defRPr>
-            </a:pPr>
-            <a:r>
-              <a:t>5 Languages</a:t>
+                  <a:srgbClr val="F43F5E"/>
+                </a:solidFill>
+              </a:defRPr>
+            </a:pPr>
+            <a:r>
+              <a:t>ScamBait AI</a:t>
             </a:r>
           </a:p>
           <a:p>
@@ -3448,7 +3448,7 @@
               </a:defRPr>
             </a:pPr>
             <a:r>
-              <a:t>Vernacular Voice Alerts</a:t>
+              <a:t>Active Honeypot Trap</a:t>
             </a:r>
           </a:p>
         </p:txBody>
@@ -3497,12 +3497,12 @@
             <a:pPr algn="ctr">
               <a:defRPr sz="2200" b="1">
                 <a:solidFill>
-                  <a:srgbClr val="67E8F9"/>
-                </a:solidFill>
-              </a:defRPr>
-            </a:pPr>
-            <a:r>
-              <a:t>3-Pillar</a:t>
+                  <a:srgbClr val="F59E0B"/>
+                </a:solidFill>
+              </a:defRPr>
+            </a:pPr>
+            <a:r>
+              <a:t>5 Languages</a:t>
             </a:r>
           </a:p>
           <a:p>
@@ -3514,7 +3514,7 @@
               </a:defRPr>
             </a:pPr>
             <a:r>
-              <a:t>Preventative Defense</a:t>
+              <a:t>Vernacular Voice Alerts</a:t>
             </a:r>
           </a:p>
         </p:txBody>
@@ -4908,7 +4908,7 @@
               </a:defRPr>
             </a:pPr>
             <a:r>
-              <a:t>AegisPay: Three-Pillar On-Device Preventative Shield</a:t>
+              <a:t>AegisPay: Four-Pillar On-Device Preventative Shield</a:t>
             </a:r>
           </a:p>
           <a:p>
@@ -4934,7 +4934,7 @@
         <p:spPr>
           <a:xfrm>
             <a:off x="731520" y="1645920"/>
-            <a:ext cx="3383280" cy="4389120"/>
+            <a:ext cx="2560320" cy="4389120"/>
           </a:xfrm>
           <a:prstGeom prst="roundRect">
             <a:avLst/>
@@ -4967,74 +4967,74 @@
           <a:lstStyle/>
           <a:p>
             <a:pPr algn="ctr">
-              <a:defRPr sz="1600" b="1">
+              <a:defRPr sz="1400" b="1">
                 <a:solidFill>
                   <a:srgbClr val="06B6D4"/>
                 </a:solidFill>
               </a:defRPr>
             </a:pPr>
             <a:r>
-              <a:t>Pillar 1: Dynamic QR Shield</a:t>
+              <a:t>Pillar 1: QR Quishing Shield</a:t>
             </a:r>
           </a:p>
           <a:p>
             <a:pPr>
               <a:spcBef>
-                <a:spcPts val="600"/>
+                <a:spcPts val="500"/>
               </a:spcBef>
-              <a:defRPr sz="1100">
+              <a:defRPr sz="1050">
                 <a:solidFill>
                   <a:srgbClr val="E2E8F0"/>
                 </a:solidFill>
               </a:defRPr>
             </a:pPr>
             <a:r>
-              <a:t>• Real-time optical AR camera parser.</a:t>
+              <a:t>• Optical AR camera parser.</a:t>
             </a:r>
           </a:p>
           <a:p>
             <a:pPr>
               <a:spcBef>
-                <a:spcPts val="600"/>
+                <a:spcPts val="500"/>
               </a:spcBef>
-              <a:defRPr sz="1100">
+              <a:defRPr sz="1050">
                 <a:solidFill>
                   <a:srgbClr val="E2E8F0"/>
                 </a:solidFill>
               </a:defRPr>
             </a:pPr>
             <a:r>
-              <a:t>• Detects Payee Name vs VPA entropy mismatches.</a:t>
+              <a:t>• Detects Payee vs VPA mismatches.</a:t>
             </a:r>
           </a:p>
           <a:p>
             <a:pPr>
               <a:spcBef>
-                <a:spcPts val="600"/>
+                <a:spcPts val="500"/>
               </a:spcBef>
-              <a:defRPr sz="1100">
+              <a:defRPr sz="1050">
                 <a:solidFill>
                   <a:srgbClr val="E2E8F0"/>
                 </a:solidFill>
               </a:defRPr>
             </a:pPr>
             <a:r>
-              <a:t>• Blocks disguised upi://collect requests.</a:t>
+              <a:t>• Blocks disguised collect requests.</a:t>
             </a:r>
           </a:p>
           <a:p>
             <a:pPr>
               <a:spcBef>
-                <a:spcPts val="600"/>
+                <a:spcPts val="500"/>
               </a:spcBef>
-              <a:defRPr sz="1100">
+              <a:defRPr sz="1050">
                 <a:solidFill>
                   <a:srgbClr val="E2E8F0"/>
                 </a:solidFill>
               </a:defRPr>
             </a:pPr>
             <a:r>
-              <a:t>• Flags amount surcharge injections in real time.</a:t>
+              <a:t>• Flags amount surcharge injections.</a:t>
             </a:r>
           </a:p>
         </p:txBody>
@@ -5047,8 +5047,8 @@
         </p:nvSpPr>
         <p:spPr>
           <a:xfrm>
-            <a:off x="4389120" y="1645920"/>
-            <a:ext cx="3383280" cy="4389120"/>
+            <a:off x="3429000" y="1645920"/>
+            <a:ext cx="2560320" cy="4389120"/>
           </a:xfrm>
           <a:prstGeom prst="roundRect">
             <a:avLst/>
@@ -5081,7 +5081,7 @@
           <a:lstStyle/>
           <a:p>
             <a:pPr algn="ctr">
-              <a:defRPr sz="1600" b="1">
+              <a:defRPr sz="1400" b="1">
                 <a:solidFill>
                   <a:srgbClr val="F59E0B"/>
                 </a:solidFill>
@@ -5094,61 +5094,61 @@
           <a:p>
             <a:pPr>
               <a:spcBef>
-                <a:spcPts val="600"/>
+                <a:spcPts val="500"/>
               </a:spcBef>
-              <a:defRPr sz="1100">
+              <a:defRPr sz="1050">
                 <a:solidFill>
                   <a:srgbClr val="E2E8F0"/>
                 </a:solidFill>
               </a:defRPr>
             </a:pPr>
             <a:r>
-              <a:t>• Quantized MobileBERT NLP model on NPU.</a:t>
+              <a:t>• Quantized MobileBERT on NPU.</a:t>
             </a:r>
           </a:p>
           <a:p>
             <a:pPr>
               <a:spcBef>
-                <a:spcPts val="600"/>
+                <a:spcPts val="500"/>
               </a:spcBef>
-              <a:defRPr sz="1100">
+              <a:defRPr sz="1050">
                 <a:solidFill>
                   <a:srgbClr val="E2E8F0"/>
                 </a:solidFill>
               </a:defRPr>
             </a:pPr>
             <a:r>
-              <a:t>• Detects urgency &amp; remote access triggers (AnyDesk).</a:t>
+              <a:t>• Detects urgency &amp; AnyDesk baits.</a:t>
             </a:r>
           </a:p>
           <a:p>
             <a:pPr>
               <a:spcBef>
-                <a:spcPts val="600"/>
+                <a:spcPts val="500"/>
               </a:spcBef>
-              <a:defRPr sz="1100">
+              <a:defRPr sz="1050">
                 <a:solidFill>
                   <a:srgbClr val="E2E8F0"/>
                 </a:solidFill>
               </a:defRPr>
             </a:pPr>
             <a:r>
-              <a:t>• Multi-lingual voice alerts (Tamil, Hindi, Telugu, Kannada).</a:t>
+              <a:t>• Multi-lingual voice alerts (Tamil/Hindi).</a:t>
             </a:r>
           </a:p>
           <a:p>
             <a:pPr>
               <a:spcBef>
-                <a:spcPts val="600"/>
+                <a:spcPts val="500"/>
               </a:spcBef>
-              <a:defRPr sz="1100">
+              <a:defRPr sz="1050">
                 <a:solidFill>
                   <a:srgbClr val="E2E8F0"/>
                 </a:solidFill>
               </a:defRPr>
             </a:pPr>
             <a:r>
-              <a:t>• Simulates Android touch barrier overlay lockdown.</a:t>
+              <a:t>• Android touch barrier overlay lock.</a:t>
             </a:r>
           </a:p>
         </p:txBody>
@@ -5161,8 +5161,8 @@
         </p:nvSpPr>
         <p:spPr>
           <a:xfrm>
-            <a:off x="8046720" y="1645920"/>
-            <a:ext cx="3383280" cy="4389120"/>
+            <a:off x="6126480" y="1645920"/>
+            <a:ext cx="2560320" cy="4389120"/>
           </a:xfrm>
           <a:prstGeom prst="roundRect">
             <a:avLst/>
@@ -5195,74 +5195,188 @@
           <a:lstStyle/>
           <a:p>
             <a:pPr algn="ctr">
-              <a:defRPr sz="1600" b="1">
+              <a:defRPr sz="1400" b="1">
                 <a:solidFill>
                   <a:srgbClr val="10B981"/>
                 </a:solidFill>
               </a:defRPr>
             </a:pPr>
             <a:r>
-              <a:t>Pillar 3: Receipt &amp; Soundbox Guard</a:t>
+              <a:t>Pillar 3: Receipt Guard</a:t>
             </a:r>
           </a:p>
           <a:p>
             <a:pPr>
               <a:spcBef>
-                <a:spcPts val="600"/>
+                <a:spcPts val="500"/>
               </a:spcBef>
-              <a:defRPr sz="1100">
+              <a:defRPr sz="1050">
                 <a:solidFill>
                   <a:srgbClr val="E2E8F0"/>
                 </a:solidFill>
               </a:defRPr>
             </a:pPr>
             <a:r>
-              <a:t>• On-device CV font-kerning anomaly detection.</a:t>
+              <a:t>• On-device CV font-kerning check.</a:t>
             </a:r>
           </a:p>
           <a:p>
             <a:pPr>
               <a:spcBef>
-                <a:spcPts val="600"/>
+                <a:spcPts val="500"/>
               </a:spcBef>
-              <a:defRPr sz="1100">
+              <a:defRPr sz="1050">
                 <a:solidFill>
                   <a:srgbClr val="E2E8F0"/>
                 </a:solidFill>
               </a:defRPr>
             </a:pPr>
             <a:r>
-              <a:t>• Luhn Mod-10 UTR checksum verification.</a:t>
+              <a:t>• Luhn Mod-10 UTR checksum.</a:t>
             </a:r>
           </a:p>
           <a:p>
             <a:pPr>
               <a:spcBef>
-                <a:spcPts val="600"/>
+                <a:spcPts val="500"/>
               </a:spcBef>
-              <a:defRPr sz="1100">
+              <a:defRPr sz="1050">
                 <a:solidFill>
                   <a:srgbClr val="E2E8F0"/>
                 </a:solidFill>
               </a:defRPr>
             </a:pPr>
             <a:r>
-              <a:t>• Validates dynamic payment animation hashes.</a:t>
+              <a:t>• Validates dynamic animation hashes.</a:t>
             </a:r>
           </a:p>
           <a:p>
             <a:pPr>
               <a:spcBef>
-                <a:spcPts val="600"/>
+                <a:spcPts val="500"/>
               </a:spcBef>
-              <a:defRPr sz="1100">
+              <a:defRPr sz="1050">
                 <a:solidFill>
                   <a:srgbClr val="E2E8F0"/>
                 </a:solidFill>
               </a:defRPr>
             </a:pPr>
             <a:r>
-              <a:t>• Catches counterfeit Paytm/GPay spoof apps offline.</a:t>
+              <a:t>• Catches fake Paytm/GPay spoof apps.</a:t>
+            </a:r>
+          </a:p>
+        </p:txBody>
+      </p:sp>
+      <p:sp>
+        <p:nvSpPr>
+          <p:cNvPr id="9" name="Rounded Rectangle 8"/>
+          <p:cNvSpPr/>
+          <p:nvPr/>
+        </p:nvSpPr>
+        <p:spPr>
+          <a:xfrm>
+            <a:off x="8823960" y="1645920"/>
+            <a:ext cx="2560320" cy="4389120"/>
+          </a:xfrm>
+          <a:prstGeom prst="roundRect">
+            <a:avLst/>
+          </a:prstGeom>
+          <a:solidFill>
+            <a:srgbClr val="0F172A"/>
+          </a:solidFill>
+          <a:ln w="19050">
+            <a:solidFill>
+              <a:srgbClr val="F43F5E"/>
+            </a:solidFill>
+          </a:ln>
+        </p:spPr>
+        <p:style>
+          <a:lnRef idx="1">
+            <a:schemeClr val="accent1"/>
+          </a:lnRef>
+          <a:fillRef idx="3">
+            <a:schemeClr val="accent1"/>
+          </a:fillRef>
+          <a:effectRef idx="2">
+            <a:schemeClr val="accent1"/>
+          </a:effectRef>
+          <a:fontRef idx="minor">
+            <a:schemeClr val="lt1"/>
+          </a:fontRef>
+        </p:style>
+        <p:txBody>
+          <a:bodyPr rtlCol="0" anchor="ctr" wrap="square"/>
+          <a:lstStyle/>
+          <a:p>
+            <a:pPr algn="ctr">
+              <a:defRPr sz="1400" b="1">
+                <a:solidFill>
+                  <a:srgbClr val="F43F5E"/>
+                </a:solidFill>
+              </a:defRPr>
+            </a:pPr>
+            <a:r>
+              <a:t>Pillar 4: 🤖 ScamBait Honeypot</a:t>
+            </a:r>
+          </a:p>
+          <a:p>
+            <a:pPr>
+              <a:spcBef>
+                <a:spcPts val="500"/>
+              </a:spcBef>
+              <a:defRPr sz="1050">
+                <a:solidFill>
+                  <a:srgbClr val="E2E8F0"/>
+                </a:solidFill>
+              </a:defRPr>
+            </a:pPr>
+            <a:r>
+              <a:t>• Autonomous AI voice persona trap.</a:t>
+            </a:r>
+          </a:p>
+          <a:p>
+            <a:pPr>
+              <a:spcBef>
+                <a:spcPts val="500"/>
+              </a:spcBef>
+              <a:defRPr sz="1050">
+                <a:solidFill>
+                  <a:srgbClr val="E2E8F0"/>
+                </a:solidFill>
+              </a:defRPr>
+            </a:pPr>
+            <a:r>
+              <a:t>• Wastes scammer time on call.</a:t>
+            </a:r>
+          </a:p>
+          <a:p>
+            <a:pPr>
+              <a:spcBef>
+                <a:spcPts val="500"/>
+              </a:spcBef>
+              <a:defRPr sz="1050">
+                <a:solidFill>
+                  <a:srgbClr val="E2E8F0"/>
+                </a:solidFill>
+              </a:defRPr>
+            </a:pPr>
+            <a:r>
+              <a:t>• Secretly extracts mule VPA handles.</a:t>
+            </a:r>
+          </a:p>
+          <a:p>
+            <a:pPr>
+              <a:spcBef>
+                <a:spcPts val="500"/>
+              </a:spcBef>
+              <a:defRPr sz="1050">
+                <a:solidFill>
+                  <a:srgbClr val="E2E8F0"/>
+                </a:solidFill>
+              </a:defRPr>
+            </a:pPr>
+            <a:r>
+              <a:t>• Auto-generates 1930 Cybercrime FIR.</a:t>
             </a:r>
           </a:p>
         </p:txBody>
@@ -7075,7 +7189,7 @@
               </a:defRPr>
             </a:pPr>
             <a:r>
-              <a:t>Lockdown UX</a:t>
+              <a:t>Lockdown &amp; Honeypot</a:t>
             </a:r>
           </a:p>
           <a:p>
@@ -7090,7 +7204,7 @@
               </a:defRPr>
             </a:pPr>
             <a:r>
-              <a:t>Android barrier overlay, biometric gate, and multi-lingual voice alerts.</a:t>
+              <a:t>Android barrier overlay, ScamBait AI persona, and multi-lingual voice alerts.</a:t>
             </a:r>
           </a:p>
         </p:txBody>
@@ -7174,7 +7288,7 @@
               </a:defRPr>
             </a:pPr>
             <a:r>
-              <a:t>Live attack scenario testing, offline validation, and final pitch deck presentation.</a:t>
+              <a:t>Live attack scenario testing, 1930 FIR validation, and final pitch presentation.</a:t>
             </a:r>
           </a:p>
         </p:txBody>
@@ -7699,7 +7813,7 @@
                         </a:defRPr>
                       </a:pPr>
                       <a:r>
-                        <a:t>Social Engineering Defense</a:t>
+                        <a:t>Active Counter-Offense</a:t>
                       </a:r>
                     </a:p>
                   </a:txBody>
@@ -7722,7 +7836,7 @@
                         </a:defRPr>
                       </a:pPr>
                       <a:r>
-                        <a:t>Static warning banners</a:t>
+                        <a:t>None (Victims left helpless)</a:t>
                       </a:r>
                     </a:p>
                   </a:txBody>
@@ -7745,7 +7859,7 @@
                         </a:defRPr>
                       </a:pPr>
                       <a:r>
-                        <a:t>Active Audio &amp; SMS NLP Interceptor</a:t>
+                        <a:t>ScamBait AI Honeypot + 1930 FIR</a:t>
                       </a:r>
                     </a:p>
                   </a:txBody>

</xml_diff>

<commit_message>
feat(fintech): align all pitch decks, pptx, and prototypes tightly around FinTech & Commerce UPI lifecycle protection
</commit_message>
<xml_diff>
--- a/AegisPay_Pitch_Deck.pptx
+++ b/AegisPay_Pitch_Deck.pptx
@@ -3150,8 +3150,8 @@
         </p:nvSpPr>
         <p:spPr>
           <a:xfrm>
-            <a:off x="4261104" y="914400"/>
-            <a:ext cx="3657600" cy="411480"/>
+            <a:off x="3931920" y="914400"/>
+            <a:ext cx="4297680" cy="411480"/>
           </a:xfrm>
           <a:prstGeom prst="roundRect">
             <a:avLst/>
@@ -3184,14 +3184,14 @@
           <a:lstStyle/>
           <a:p>
             <a:pPr algn="ctr">
-              <a:defRPr sz="1100" b="1">
+              <a:defRPr sz="1050" b="1">
                 <a:solidFill>
                   <a:srgbClr val="67E8F9"/>
                 </a:solidFill>
               </a:defRPr>
             </a:pPr>
             <a:r>
-              <a:t>⚡ iQOO HACKATHON 2026 SUBMISSION</a:t>
+              <a:t>⚡ iQOO HACKATHON 2026: FINTECH &amp; COMMERCE TRACK</a:t>
             </a:r>
           </a:p>
         </p:txBody>
@@ -3238,7 +3238,7 @@
               </a:defRPr>
             </a:pPr>
             <a:r>
-              <a:t>Autonomous On-Device AI Guardian for UPI &amp; QR Fraud Prevention</a:t>
+              <a:t>Autonomous On-Device AI Guardian for UPI Payments &amp; Retail Commerce</a:t>
             </a:r>
           </a:p>
           <a:p>
@@ -3250,7 +3250,7 @@
               </a:defRPr>
             </a:pPr>
             <a:r>
-              <a:t>Track: FinTech &amp; Commerce  |  Team: Team AegisPay</a:t>
+              <a:t>Track: FinTech &amp; Commerce  |  Team: Team AegisPay  |  Target: 14B+ Monthly UPI Transactions</a:t>
             </a:r>
           </a:p>
         </p:txBody>
@@ -3382,7 +3382,7 @@
               </a:defRPr>
             </a:pPr>
             <a:r>
-              <a:t>Zero Cloud Telemetry</a:t>
+              <a:t>DPDP Act Zero Cloud Leak</a:t>
             </a:r>
           </a:p>
         </p:txBody>
@@ -3448,7 +3448,7 @@
               </a:defRPr>
             </a:pPr>
             <a:r>
-              <a:t>Active Honeypot Trap</a:t>
+              <a:t>Mule VPA Sting &amp; 1930 FIR</a:t>
             </a:r>
           </a:p>
         </p:txBody>
@@ -3625,8 +3625,8 @@
         </p:nvSpPr>
         <p:spPr>
           <a:xfrm>
-            <a:off x="4261104" y="914400"/>
-            <a:ext cx="3657600" cy="411480"/>
+            <a:off x="3931920" y="914400"/>
+            <a:ext cx="4297680" cy="411480"/>
           </a:xfrm>
           <a:prstGeom prst="roundRect">
             <a:avLst/>
@@ -3694,14 +3694,14 @@
           <a:lstStyle/>
           <a:p>
             <a:pPr algn="ctr">
-              <a:defRPr sz="4000" b="1">
+              <a:defRPr sz="3800" b="1">
                 <a:solidFill>
                   <a:srgbClr val="FFFFFF"/>
                 </a:solidFill>
               </a:defRPr>
             </a:pPr>
             <a:r>
-              <a:t>Protecting 300+ Million Digital Citizens</a:t>
+              <a:t>Securing India's 14+ Billion Monthly UPI Economy</a:t>
             </a:r>
           </a:p>
           <a:p>
@@ -3713,7 +3713,7 @@
               </a:defRPr>
             </a:pPr>
             <a:r>
-              <a:t>Turning every smartphone into an autonomous, impenetrable personal security vault.</a:t>
+              <a:t>Protecting 300+ Million consumers and 50+ Million retail merchants with zero-trust payment security.</a:t>
             </a:r>
           </a:p>
         </p:txBody>
@@ -3863,7 +3863,7 @@
         <p:spPr>
           <a:xfrm>
             <a:off x="731520" y="365760"/>
-            <a:ext cx="2560320" cy="320040"/>
+            <a:ext cx="2926080" cy="320040"/>
           </a:xfrm>
           <a:prstGeom prst="roundRect">
             <a:avLst/>
@@ -3903,7 +3903,7 @@
               </a:defRPr>
             </a:pPr>
             <a:r>
-              <a:t>01. THE PROBLEM STATEMENT</a:t>
+              <a:t>01. FINTECH PROBLEM</a:t>
             </a:r>
           </a:p>
         </p:txBody>
@@ -3985,7 +3985,7 @@
               </a:defRPr>
             </a:pPr>
             <a:r>
-              <a:t>Over 14 Billion UPI transactions occur monthly, but digital fraud has exploded proportionally.</a:t>
+              <a:t>Over 14 Billion UPI transactions occur monthly, but 98% of fraud occurs at the consumer-merchant interface.</a:t>
             </a:r>
           </a:p>
         </p:txBody>
@@ -4039,7 +4039,7 @@
               </a:defRPr>
             </a:pPr>
             <a:r>
-              <a:t>1. QR Quishing Stickers</a:t>
+              <a:t>1. Retail QR Quishing</a:t>
             </a:r>
           </a:p>
           <a:p>
@@ -4054,7 +4054,7 @@
               </a:defRPr>
             </a:pPr>
             <a:r>
-              <a:t>Malicious stickers pasted over authentic merchant QR codes silently route payments to mule accounts.</a:t>
+              <a:t>Malicious stickers pasted over authentic merchant QR stands divert payments to mule accounts.</a:t>
             </a:r>
           </a:p>
         </p:txBody>
@@ -4108,7 +4108,7 @@
               </a:defRPr>
             </a:pPr>
             <a:r>
-              <a:t>2. Reverse PIN Deception</a:t>
+              <a:t>2. Reverse Collect &amp; Mandates</a:t>
             </a:r>
           </a:p>
           <a:p>
@@ -4123,7 +4123,7 @@
               </a:defRPr>
             </a:pPr>
             <a:r>
-              <a:t>Victims are tricked via phone calls to enter their 6-digit PIN under the claim of receiving cashback or refund credits.</a:t>
+              <a:t>Victims are tricked via fake calls to enter their PIN to 'receive' money, or sign deceptive ₹9,999/mo e-Mandates.</a:t>
             </a:r>
           </a:p>
         </p:txBody>
@@ -4177,7 +4177,7 @@
               </a:defRPr>
             </a:pPr>
             <a:r>
-              <a:t>3. Counterfeit Receipt Apps</a:t>
+              <a:t>3. Kirana Merchant Fraud</a:t>
             </a:r>
           </a:p>
           <a:p>
@@ -4192,7 +4192,7 @@
               </a:defRPr>
             </a:pPr>
             <a:r>
-              <a:t>Spoofed payment confirmation apps display fake green checkmarks and simulated soundbox chimes to dupe Kirana merchants.</a:t>
+              <a:t>Spoofed payment confirmation apps display fake green ticks and soundbox chimes to steal retail goods.</a:t>
             </a:r>
           </a:p>
         </p:txBody>
@@ -4246,7 +4246,7 @@
               </a:defRPr>
             </a:pPr>
             <a:r>
-              <a:t>🎯 High-Risk Demographics: 68% of victims are first-time digital users, elderly citizens, and vernacular speakers in Tier-2/3 cities who lack cybersecurity awareness.</a:t>
+              <a:t>🎯 High-Risk Demographics: 68% of victims are first-time digital citizens, elderly users, and vernacular speakers in Tier-2/3 retail markets.</a:t>
             </a:r>
           </a:p>
         </p:txBody>
@@ -4323,7 +4323,7 @@
         <p:spPr>
           <a:xfrm>
             <a:off x="731520" y="365760"/>
-            <a:ext cx="2560320" cy="320040"/>
+            <a:ext cx="2926080" cy="320040"/>
           </a:xfrm>
           <a:prstGeom prst="roundRect">
             <a:avLst/>
@@ -4363,7 +4363,7 @@
               </a:defRPr>
             </a:pPr>
             <a:r>
-              <a:t>02. THE EXISTING GAP</a:t>
+              <a:t>02. THE FINTECH GAP</a:t>
             </a:r>
           </a:p>
         </p:txBody>
@@ -4433,7 +4433,7 @@
               </a:defRPr>
             </a:pPr>
             <a:r>
-              <a:t>Why Cloud-Based Security &amp; Antivirus Defenses Fail</a:t>
+              <a:t>Why Cloud-Based Banking Security APIs Fail</a:t>
             </a:r>
           </a:p>
           <a:p>
@@ -4445,7 +4445,7 @@
               </a:defRPr>
             </a:pPr>
             <a:r>
-              <a:t>Traditional cloud APIs cannot prevent split-second fraud before money leaves the bank.</a:t>
+              <a:t>Traditional cloud APIs cannot stop split-second fraud before money leaves the bank account.</a:t>
             </a:r>
           </a:p>
         </p:txBody>
@@ -4499,7 +4499,7 @@
               </a:defRPr>
             </a:pPr>
             <a:r>
-              <a:t>❌ Cloud Latency (800ms – 2,500ms)</a:t>
+              <a:t>❌ Cloud Latency (1,200ms – 3,000ms)</a:t>
             </a:r>
           </a:p>
           <a:p>
@@ -4514,7 +4514,7 @@
               </a:defRPr>
             </a:pPr>
             <a:r>
-              <a:t>Fraud happens in milliseconds. Cloud roundtrips cannot stop an impulsive user tap before money leaves the bank.</a:t>
+              <a:t>UPI transactions happen in split-seconds. Cloud roundtrips cannot stop an impulsive user tap before money leaves the bank.</a:t>
             </a:r>
           </a:p>
         </p:txBody>
@@ -4583,7 +4583,7 @@
               </a:defRPr>
             </a:pPr>
             <a:r>
-              <a:t>Transmitting user SMS messages, OTPs, and personal VPA histories to remote servers introduces serious data leakage.</a:t>
+              <a:t>Transmitting user SMS messages, OTPs, and personal VPA histories to remote servers introduces serious financial data breach liabilities.</a:t>
             </a:r>
           </a:p>
         </p:txBody>
@@ -4637,7 +4637,7 @@
               </a:defRPr>
             </a:pPr>
             <a:r>
-              <a:t>❌ Offline &amp; Rural Blindspots</a:t>
+              <a:t>❌ Offline &amp; Rural Market Blindspots</a:t>
             </a:r>
           </a:p>
           <a:p>
@@ -4798,7 +4798,7 @@
         <p:spPr>
           <a:xfrm>
             <a:off x="731520" y="365760"/>
-            <a:ext cx="2560320" cy="320040"/>
+            <a:ext cx="2926080" cy="320040"/>
           </a:xfrm>
           <a:prstGeom prst="roundRect">
             <a:avLst/>
@@ -4908,7 +4908,7 @@
               </a:defRPr>
             </a:pPr>
             <a:r>
-              <a:t>AegisPay: Four-Pillar On-Device Preventative Shield</a:t>
+              <a:t>AegisPay: 4-Pillar On-Device FinTech &amp; Commerce Shield</a:t>
             </a:r>
           </a:p>
           <a:p>
@@ -4920,7 +4920,7 @@
               </a:defRPr>
             </a:pPr>
             <a:r>
-              <a:t>Autonomous edge intelligence that protects users before, during, and after payment initiation.</a:t>
+              <a:t>Autonomous edge intelligence that protects the entire 14B+ monthly UPI transaction lifecycle.</a:t>
             </a:r>
           </a:p>
         </p:txBody>
@@ -4974,7 +4974,7 @@
               </a:defRPr>
             </a:pPr>
             <a:r>
-              <a:t>Pillar 1: QR Quishing Shield</a:t>
+              <a:t>01. QR Ingress Shield</a:t>
             </a:r>
           </a:p>
           <a:p>
@@ -4989,7 +4989,7 @@
               </a:defRPr>
             </a:pPr>
             <a:r>
-              <a:t>• Optical AR camera parser.</a:t>
+              <a:t>• 3D optical parallax depth scan.</a:t>
             </a:r>
           </a:p>
           <a:p>
@@ -5004,7 +5004,7 @@
               </a:defRPr>
             </a:pPr>
             <a:r>
-              <a:t>• Detects Payee vs VPA mismatches.</a:t>
+              <a:t>• Measures +0.35mm sticker depth.</a:t>
             </a:r>
           </a:p>
           <a:p>
@@ -5019,7 +5019,7 @@
               </a:defRPr>
             </a:pPr>
             <a:r>
-              <a:t>• Blocks disguised collect requests.</a:t>
+              <a:t>• NPCI URI deep parser (pa, pn, am).</a:t>
             </a:r>
           </a:p>
           <a:p>
@@ -5034,7 +5034,7 @@
               </a:defRPr>
             </a:pPr>
             <a:r>
-              <a:t>• Flags amount surcharge injections.</a:t>
+              <a:t>• Blocks disguised collect requests.</a:t>
             </a:r>
           </a:p>
         </p:txBody>
@@ -5048,6 +5048,120 @@
         <p:spPr>
           <a:xfrm>
             <a:off x="3429000" y="1645920"/>
+            <a:ext cx="2560320" cy="4389120"/>
+          </a:xfrm>
+          <a:prstGeom prst="roundRect">
+            <a:avLst/>
+          </a:prstGeom>
+          <a:solidFill>
+            <a:srgbClr val="0F172A"/>
+          </a:solidFill>
+          <a:ln w="19050">
+            <a:solidFill>
+              <a:srgbClr val="F43F5E"/>
+            </a:solidFill>
+          </a:ln>
+        </p:spPr>
+        <p:style>
+          <a:lnRef idx="1">
+            <a:schemeClr val="accent1"/>
+          </a:lnRef>
+          <a:fillRef idx="3">
+            <a:schemeClr val="accent1"/>
+          </a:fillRef>
+          <a:effectRef idx="2">
+            <a:schemeClr val="accent1"/>
+          </a:effectRef>
+          <a:fontRef idx="minor">
+            <a:schemeClr val="lt1"/>
+          </a:fontRef>
+        </p:style>
+        <p:txBody>
+          <a:bodyPr rtlCol="0" anchor="ctr" wrap="square"/>
+          <a:lstStyle/>
+          <a:p>
+            <a:pPr algn="ctr">
+              <a:defRPr sz="1400" b="1">
+                <a:solidFill>
+                  <a:srgbClr val="F43F5E"/>
+                </a:solidFill>
+              </a:defRPr>
+            </a:pPr>
+            <a:r>
+              <a:t>02. Deepfake &amp; Coercion</a:t>
+            </a:r>
+          </a:p>
+          <a:p>
+            <a:pPr>
+              <a:spcBef>
+                <a:spcPts val="500"/>
+              </a:spcBef>
+              <a:defRPr sz="1050">
+                <a:solidFill>
+                  <a:srgbClr val="E2E8F0"/>
+                </a:solidFill>
+              </a:defRPr>
+            </a:pPr>
+            <a:r>
+              <a:t>• Mel-spectrogram AI on NPU.</a:t>
+            </a:r>
+          </a:p>
+          <a:p>
+            <a:pPr>
+              <a:spcBef>
+                <a:spcPts val="500"/>
+              </a:spcBef>
+              <a:defRPr sz="1050">
+                <a:solidFill>
+                  <a:srgbClr val="E2E8F0"/>
+                </a:solidFill>
+              </a:defRPr>
+            </a:pPr>
+            <a:r>
+              <a:t>• Catches AI voice clones on call.</a:t>
+            </a:r>
+          </a:p>
+          <a:p>
+            <a:pPr>
+              <a:spcBef>
+                <a:spcPts val="500"/>
+              </a:spcBef>
+              <a:defRPr sz="1050">
+                <a:solidFill>
+                  <a:srgbClr val="E2E8F0"/>
+                </a:solidFill>
+              </a:defRPr>
+            </a:pPr>
+            <a:r>
+              <a:t>• Quantized MobileBERT NLP model.</a:t>
+            </a:r>
+          </a:p>
+          <a:p>
+            <a:pPr>
+              <a:spcBef>
+                <a:spcPts val="500"/>
+              </a:spcBef>
+              <a:defRPr sz="1050">
+                <a:solidFill>
+                  <a:srgbClr val="E2E8F0"/>
+                </a:solidFill>
+              </a:defRPr>
+            </a:pPr>
+            <a:r>
+              <a:t>• Android touch barrier overlay lock.</a:t>
+            </a:r>
+          </a:p>
+        </p:txBody>
+      </p:sp>
+      <p:sp>
+        <p:nvSpPr>
+          <p:cNvPr id="8" name="Rounded Rectangle 7"/>
+          <p:cNvSpPr/>
+          <p:nvPr/>
+        </p:nvSpPr>
+        <p:spPr>
+          <a:xfrm>
+            <a:off x="6126480" y="1645920"/>
             <a:ext cx="2560320" cy="4389120"/>
           </a:xfrm>
           <a:prstGeom prst="roundRect">
@@ -5088,7 +5202,7 @@
               </a:defRPr>
             </a:pPr>
             <a:r>
-              <a:t>Pillar 2: Social Eng. Interceptor</a:t>
+              <a:t>03. ScamBait Honeypot</a:t>
             </a:r>
           </a:p>
           <a:p>
@@ -5103,7 +5217,7 @@
               </a:defRPr>
             </a:pPr>
             <a:r>
-              <a:t>• Quantized MobileBERT on NPU.</a:t>
+              <a:t>• Autonomous AI voice persona.</a:t>
             </a:r>
           </a:p>
           <a:p>
@@ -5118,7 +5232,7 @@
               </a:defRPr>
             </a:pPr>
             <a:r>
-              <a:t>• Detects urgency &amp; AnyDesk baits.</a:t>
+              <a:t>• Stalls scammer for 15+ minutes.</a:t>
             </a:r>
           </a:p>
           <a:p>
@@ -5133,7 +5247,7 @@
               </a:defRPr>
             </a:pPr>
             <a:r>
-              <a:t>• Multi-lingual voice alerts (Tamil/Hindi).</a:t>
+              <a:t>• Extracts real mule UPI handles.</a:t>
             </a:r>
           </a:p>
           <a:p>
@@ -5148,20 +5262,20 @@
               </a:defRPr>
             </a:pPr>
             <a:r>
-              <a:t>• Android touch barrier overlay lock.</a:t>
-            </a:r>
-          </a:p>
-        </p:txBody>
-      </p:sp>
-      <p:sp>
-        <p:nvSpPr>
-          <p:cNvPr id="8" name="Rounded Rectangle 7"/>
+              <a:t>• Auto-generates 1930 Police FIR.</a:t>
+            </a:r>
+          </a:p>
+        </p:txBody>
+      </p:sp>
+      <p:sp>
+        <p:nvSpPr>
+          <p:cNvPr id="9" name="Rounded Rectangle 8"/>
           <p:cNvSpPr/>
           <p:nvPr/>
         </p:nvSpPr>
         <p:spPr>
           <a:xfrm>
-            <a:off x="6126480" y="1645920"/>
+            <a:off x="8823960" y="1645920"/>
             <a:ext cx="2560320" cy="4389120"/>
           </a:xfrm>
           <a:prstGeom prst="roundRect">
@@ -5202,7 +5316,7 @@
               </a:defRPr>
             </a:pPr>
             <a:r>
-              <a:t>Pillar 3: Receipt Guard</a:t>
+              <a:t>04. Kirana &amp; Mandate</a:t>
             </a:r>
           </a:p>
           <a:p>
@@ -5217,7 +5331,7 @@
               </a:defRPr>
             </a:pPr>
             <a:r>
-              <a:t>• On-device CV font-kerning check.</a:t>
+              <a:t>• Luhn Mod-10 UTR checksum.</a:t>
             </a:r>
           </a:p>
           <a:p>
@@ -5232,7 +5346,7 @@
               </a:defRPr>
             </a:pPr>
             <a:r>
-              <a:t>• Luhn Mod-10 UTR checksum.</a:t>
+              <a:t>• CV font-kerning anomaly check.</a:t>
             </a:r>
           </a:p>
           <a:p>
@@ -5247,7 +5361,7 @@
               </a:defRPr>
             </a:pPr>
             <a:r>
-              <a:t>• Validates dynamic animation hashes.</a:t>
+              <a:t>• Unmasks hidden AutoPay debits.</a:t>
             </a:r>
           </a:p>
           <a:p>
@@ -5262,121 +5376,7 @@
               </a:defRPr>
             </a:pPr>
             <a:r>
-              <a:t>• Catches fake Paytm/GPay spoof apps.</a:t>
-            </a:r>
-          </a:p>
-        </p:txBody>
-      </p:sp>
-      <p:sp>
-        <p:nvSpPr>
-          <p:cNvPr id="9" name="Rounded Rectangle 8"/>
-          <p:cNvSpPr/>
-          <p:nvPr/>
-        </p:nvSpPr>
-        <p:spPr>
-          <a:xfrm>
-            <a:off x="8823960" y="1645920"/>
-            <a:ext cx="2560320" cy="4389120"/>
-          </a:xfrm>
-          <a:prstGeom prst="roundRect">
-            <a:avLst/>
-          </a:prstGeom>
-          <a:solidFill>
-            <a:srgbClr val="0F172A"/>
-          </a:solidFill>
-          <a:ln w="19050">
-            <a:solidFill>
-              <a:srgbClr val="F43F5E"/>
-            </a:solidFill>
-          </a:ln>
-        </p:spPr>
-        <p:style>
-          <a:lnRef idx="1">
-            <a:schemeClr val="accent1"/>
-          </a:lnRef>
-          <a:fillRef idx="3">
-            <a:schemeClr val="accent1"/>
-          </a:fillRef>
-          <a:effectRef idx="2">
-            <a:schemeClr val="accent1"/>
-          </a:effectRef>
-          <a:fontRef idx="minor">
-            <a:schemeClr val="lt1"/>
-          </a:fontRef>
-        </p:style>
-        <p:txBody>
-          <a:bodyPr rtlCol="0" anchor="ctr" wrap="square"/>
-          <a:lstStyle/>
-          <a:p>
-            <a:pPr algn="ctr">
-              <a:defRPr sz="1400" b="1">
-                <a:solidFill>
-                  <a:srgbClr val="F43F5E"/>
-                </a:solidFill>
-              </a:defRPr>
-            </a:pPr>
-            <a:r>
-              <a:t>Pillar 4: 🤖 ScamBait Honeypot</a:t>
-            </a:r>
-          </a:p>
-          <a:p>
-            <a:pPr>
-              <a:spcBef>
-                <a:spcPts val="500"/>
-              </a:spcBef>
-              <a:defRPr sz="1050">
-                <a:solidFill>
-                  <a:srgbClr val="E2E8F0"/>
-                </a:solidFill>
-              </a:defRPr>
-            </a:pPr>
-            <a:r>
-              <a:t>• Autonomous AI voice persona trap.</a:t>
-            </a:r>
-          </a:p>
-          <a:p>
-            <a:pPr>
-              <a:spcBef>
-                <a:spcPts val="500"/>
-              </a:spcBef>
-              <a:defRPr sz="1050">
-                <a:solidFill>
-                  <a:srgbClr val="E2E8F0"/>
-                </a:solidFill>
-              </a:defRPr>
-            </a:pPr>
-            <a:r>
-              <a:t>• Wastes scammer time on call.</a:t>
-            </a:r>
-          </a:p>
-          <a:p>
-            <a:pPr>
-              <a:spcBef>
-                <a:spcPts val="500"/>
-              </a:spcBef>
-              <a:defRPr sz="1050">
-                <a:solidFill>
-                  <a:srgbClr val="E2E8F0"/>
-                </a:solidFill>
-              </a:defRPr>
-            </a:pPr>
-            <a:r>
-              <a:t>• Secretly extracts mule VPA handles.</a:t>
-            </a:r>
-          </a:p>
-          <a:p>
-            <a:pPr>
-              <a:spcBef>
-                <a:spcPts val="500"/>
-              </a:spcBef>
-              <a:defRPr sz="1050">
-                <a:solidFill>
-                  <a:srgbClr val="E2E8F0"/>
-                </a:solidFill>
-              </a:defRPr>
-            </a:pPr>
-            <a:r>
-              <a:t>• Auto-generates 1930 Cybercrime FIR.</a:t>
+              <a:t>• Acoustic soundbox tone validator.</a:t>
             </a:r>
           </a:p>
         </p:txBody>
@@ -5453,7 +5453,7 @@
         <p:spPr>
           <a:xfrm>
             <a:off x="731520" y="365760"/>
-            <a:ext cx="2560320" cy="320040"/>
+            <a:ext cx="2926080" cy="320040"/>
           </a:xfrm>
           <a:prstGeom prst="roundRect">
             <a:avLst/>
@@ -5782,7 +5782,7 @@
               </a:defRPr>
             </a:pPr>
             <a:r>
-              <a:t>High-frequency sensory vibration pulses snap victims out of emotional panic during coercive voice calls.</a:t>
+              <a:t>High-frequency sensory vibration pulses snap victims out of emotional panic during coercive scam calls.</a:t>
             </a:r>
           </a:p>
         </p:txBody>
@@ -5928,7 +5928,7 @@
         <p:spPr>
           <a:xfrm>
             <a:off x="731520" y="365760"/>
-            <a:ext cx="2560320" cy="320040"/>
+            <a:ext cx="2926080" cy="320040"/>
           </a:xfrm>
           <a:prstGeom prst="roundRect">
             <a:avLst/>
@@ -6170,7 +6170,7 @@
               </a:defRPr>
             </a:pPr>
             <a:r>
-              <a:t>MobileBERT-INT8 (18 MB)</a:t>
+              <a:t>MobileBERT + Mel-Transformer (18MB)</a:t>
             </a:r>
           </a:p>
           <a:p>
@@ -6182,7 +6182,7 @@
               </a:defRPr>
             </a:pPr>
             <a:r>
-              <a:t>Quantized Model</a:t>
+              <a:t>Quantized Models</a:t>
             </a:r>
           </a:p>
         </p:txBody>
@@ -6424,7 +6424,7 @@
         <p:spPr>
           <a:xfrm>
             <a:off x="731520" y="365760"/>
-            <a:ext cx="2560320" cy="320040"/>
+            <a:ext cx="2926080" cy="320040"/>
           </a:xfrm>
           <a:prstGeom prst="roundRect">
             <a:avLst/>
@@ -6830,7 +6830,7 @@
         <p:spPr>
           <a:xfrm>
             <a:off x="731520" y="365760"/>
-            <a:ext cx="2560320" cy="320040"/>
+            <a:ext cx="2926080" cy="320040"/>
           </a:xfrm>
           <a:prstGeom prst="roundRect">
             <a:avLst/>
@@ -7365,7 +7365,7 @@
         <p:spPr>
           <a:xfrm>
             <a:off x="731520" y="365760"/>
-            <a:ext cx="2560320" cy="320040"/>
+            <a:ext cx="2926080" cy="320040"/>
           </a:xfrm>
           <a:prstGeom prst="roundRect">
             <a:avLst/>
@@ -7475,7 +7475,7 @@
               </a:defRPr>
             </a:pPr>
             <a:r>
-              <a:t>Why AegisPay Wins Against Existing Solutions</a:t>
+              <a:t>Why AegisPay Wins in FinTech</a:t>
             </a:r>
           </a:p>
           <a:p>

</xml_diff>